<commit_message>
L4 deck: fix double-encoded footer/metadata text; embed Aptos in PDFs
- repaired mojibake in the L4 generator's footer and doc metadata
- installed the official Aptos fonts so PowerPoint's PDF export embeds
  real glyphs instead of a broken substitute (fixes garbled bullets,
  dashes and middots across all four converted decks)

Co-authored-by: Copilot <223556219+Copilot@users.noreply.github.com>
</commit_message>
<xml_diff>
--- a/public/downloads/US-114050-L4-Business-Information-Needs.pptx
+++ b/public/downloads/US-114050-L4-Business-Information-Needs.pptx
@@ -2586,7 +2586,7 @@
                 <a:ea typeface="Aptos" pitchFamily="34" charset="-122"/>
                 <a:cs typeface="Aptos" pitchFamily="34" charset="-120"/>
               </a:rPr>
-              <a:t>US 114050 Â· Lesson 4 â€” The business and its information needs Â· NQF 5</a:t>
+              <a:t>US 114050 · Lesson 4 — The business and its information needs · NQF 5</a:t>
             </a:r>
             <a:endParaRPr lang="en-US" sz="1800" dirty="0"/>
           </a:p>
@@ -3238,7 +3238,7 @@
                 <a:ea typeface="Aptos" pitchFamily="34" charset="-122"/>
                 <a:cs typeface="Aptos" pitchFamily="34" charset="-120"/>
               </a:rPr>
-              <a:t>US 114050 Â· Lesson 4 â€” The business and its information needs Â· NQF 5</a:t>
+              <a:t>US 114050 · Lesson 4 — The business and its information needs · NQF 5</a:t>
             </a:r>
             <a:endParaRPr lang="en-US" sz="1800" dirty="0"/>
           </a:p>
@@ -4166,7 +4166,7 @@
                 <a:ea typeface="Aptos" pitchFamily="34" charset="-122"/>
                 <a:cs typeface="Aptos" pitchFamily="34" charset="-120"/>
               </a:rPr>
-              <a:t>US 114050 Â· Lesson 4 â€” The business and its information needs Â· NQF 5</a:t>
+              <a:t>US 114050 · Lesson 4 — The business and its information needs · NQF 5</a:t>
             </a:r>
             <a:endParaRPr lang="en-US" sz="1800" dirty="0"/>
           </a:p>
@@ -4966,7 +4966,7 @@
                 <a:ea typeface="Aptos" pitchFamily="34" charset="-122"/>
                 <a:cs typeface="Aptos" pitchFamily="34" charset="-120"/>
               </a:rPr>
-              <a:t>US 114050 Â· Lesson 4 â€” The business and its information needs Â· NQF 5</a:t>
+              <a:t>US 114050 · Lesson 4 — The business and its information needs · NQF 5</a:t>
             </a:r>
             <a:endParaRPr lang="en-US" sz="1800" dirty="0"/>
           </a:p>
@@ -5266,7 +5266,7 @@
                 <a:ea typeface="Aptos" pitchFamily="34" charset="-122"/>
                 <a:cs typeface="Aptos" pitchFamily="34" charset="-120"/>
               </a:rPr>
-              <a:t>US 114050 Â· Lesson 4 â€” The business and its information needs Â· NQF 5</a:t>
+              <a:t>US 114050 · Lesson 4 — The business and its information needs · NQF 5</a:t>
             </a:r>
             <a:endParaRPr lang="en-US" sz="1800" dirty="0"/>
           </a:p>
@@ -6371,7 +6371,7 @@
                 <a:ea typeface="Aptos" pitchFamily="34" charset="-122"/>
                 <a:cs typeface="Aptos" pitchFamily="34" charset="-120"/>
               </a:rPr>
-              <a:t>US 114050 Â· Lesson 4 â€” The business and its information needs Â· NQF 5</a:t>
+              <a:t>US 114050 · Lesson 4 — The business and its information needs · NQF 5</a:t>
             </a:r>
             <a:endParaRPr lang="en-US" sz="1800" dirty="0"/>
           </a:p>
@@ -6990,7 +6990,7 @@
                 <a:ea typeface="Aptos" pitchFamily="34" charset="-122"/>
                 <a:cs typeface="Aptos" pitchFamily="34" charset="-120"/>
               </a:rPr>
-              <a:t>US 114050 Â· Lesson 4 â€” The business and its information needs Â· NQF 5</a:t>
+              <a:t>US 114050 · Lesson 4 — The business and its information needs · NQF 5</a:t>
             </a:r>
             <a:endParaRPr lang="en-US" sz="1800" dirty="0"/>
           </a:p>
@@ -7757,7 +7757,7 @@
                 <a:ea typeface="Aptos" pitchFamily="34" charset="-122"/>
                 <a:cs typeface="Aptos" pitchFamily="34" charset="-120"/>
               </a:rPr>
-              <a:t>US 114050 Â· Lesson 4 â€” The business and its information needs Â· NQF 5</a:t>
+              <a:t>US 114050 · Lesson 4 — The business and its information needs · NQF 5</a:t>
             </a:r>
             <a:endParaRPr lang="en-US" sz="1800" dirty="0"/>
           </a:p>
@@ -8198,7 +8198,7 @@
                 <a:ea typeface="Aptos" pitchFamily="34" charset="-122"/>
                 <a:cs typeface="Aptos" pitchFamily="34" charset="-120"/>
               </a:rPr>
-              <a:t>US 114050 Â· Lesson 4 â€” The business and its information needs Â· NQF 5</a:t>
+              <a:t>US 114050 · Lesson 4 — The business and its information needs · NQF 5</a:t>
             </a:r>
             <a:endParaRPr lang="en-US" sz="1800" dirty="0"/>
           </a:p>
@@ -8548,7 +8548,7 @@
                 <a:ea typeface="Aptos" pitchFamily="34" charset="-122"/>
                 <a:cs typeface="Aptos" pitchFamily="34" charset="-120"/>
               </a:rPr>
-              <a:t>US 114050 Â· Lesson 4 â€” The business and its information needs Â· NQF 5</a:t>
+              <a:t>US 114050 · Lesson 4 — The business and its information needs · NQF 5</a:t>
             </a:r>
             <a:endParaRPr lang="en-US" sz="1800" dirty="0"/>
           </a:p>
@@ -9167,7 +9167,7 @@
                 <a:ea typeface="Aptos" pitchFamily="34" charset="-122"/>
                 <a:cs typeface="Aptos" pitchFamily="34" charset="-120"/>
               </a:rPr>
-              <a:t>US 114050 Â· Lesson 4 â€” The business and its information needs Â· NQF 5</a:t>
+              <a:t>US 114050 · Lesson 4 — The business and its information needs · NQF 5</a:t>
             </a:r>
             <a:endParaRPr lang="en-US" sz="1800" dirty="0"/>
           </a:p>
@@ -10124,7 +10124,7 @@
                 <a:ea typeface="Aptos" pitchFamily="34" charset="-122"/>
                 <a:cs typeface="Aptos" pitchFamily="34" charset="-120"/>
               </a:rPr>
-              <a:t>US 114050 Â· Lesson 4 â€” The business and its information needs Â· NQF 5</a:t>
+              <a:t>US 114050 · Lesson 4 — The business and its information needs · NQF 5</a:t>
             </a:r>
             <a:endParaRPr lang="en-US" sz="1800" dirty="0"/>
           </a:p>

</xml_diff>